<commit_message>
Fix a misleading read on slide 8: 2.5 claims/day is demand, not a cap
"20 claim handlers x 2.5 claims a day... 52 min back, each, per day" could
be misread as "after the redesign a handler still only processes 2.5
claims a day," as if the AI barely moved throughput. That's backwards:
2.5 is the inbound rate (50 first reports a day / 20 handlers), fixed by
how many claims arrive, not by how fast a handler can work them.

The line now says what actually changes and what doesn't: 2.5 first
reports a day per handler, the same before and after, inbound volume,
not a capacity cap; what changes is the 100 minutes a day that volume
used to cost, now 48.

No figures changed, this is the same claimsPerPersonDay / intakeMinPersonDay
/ afterMinPersonDay figures.json already computed, just stated so the
reader can't draw the wrong conclusion from it.

Co-Authored-By: Claude Sonnet 5 <noreply@anthropic.com>
Claude-Session: https://claude.ai/code/session_013ahPfefW92ASgTXBvzAPvh
</commit_message>
<xml_diff>
--- a/case-study/deck/GGW_FNOL_Redesign.pptx
+++ b/case-study/deck/GGW_FNOL_Redesign.pptx
@@ -25089,7 +25089,7 @@
         <p:spPr>
           <a:xfrm>
             <a:off x="365760" y="4224528"/>
-            <a:ext cx="5650992" cy="274320"/>
+            <a:ext cx="5650992" cy="384048"/>
           </a:xfrm>
           <a:prstGeom prst="rect">
             <a:avLst/>
@@ -25116,7 +25116,7 @@
                 <a:ea typeface="Arial" pitchFamily="34" charset="-122"/>
                 <a:cs typeface="Arial" pitchFamily="34" charset="-120"/>
               </a:rPr>
-              <a:t>Basis: 20 claim handlers × 2.5 claims a day, confirmed by GGW (8 Sep 2026). 52 min back, each, per day.</a:t>
+              <a:t>Basis: 2.5 first reports a day per handler, the same before and after, that's inbound volume, not a capacity cap. What changes is the time each takes: 100 minutes a day, then 48. Confirmed by GGW (8 Sep 2026).</a:t>
             </a:r>
             <a:endParaRPr lang="en-US" sz="860" dirty="0"/>
           </a:p>

</xml_diff>

<commit_message>
Ground the 2.5-claims-a-day figure against a real 8-hour shift
2.5 = 50 first reports a day / 20 handlers, both GGW-confirmed, arithmetic
was never wrong. But left bare next to a 40-minute-per-claim figure, it
reads as implausibly low against an 8-hour shift, which is exactly what
led to this fix: state the share directly instead of making the reader
compute it.

The basis line on slide 8 now says: 100 minutes of an 8-hour shift today
(~21%), 48 after (~10%), and names where the rest of the day goes,
claims already open, not new intake. Same figures.json inputs
(claimsPerPersonDay, stdTodayInt, intakeMinPersonDay, afterMinPersonDay),
no new numbers, just spelled out against a shift length nobody has to
look up.

Co-Authored-By: Claude Sonnet 5 <noreply@anthropic.com>
Claude-Session: https://claude.ai/code/session_013ahPfefW92ASgTXBvzAPvh
</commit_message>
<xml_diff>
--- a/case-study/deck/GGW_FNOL_Redesign.pptx
+++ b/case-study/deck/GGW_FNOL_Redesign.pptx
@@ -25089,7 +25089,7 @@
         <p:spPr>
           <a:xfrm>
             <a:off x="365760" y="4224528"/>
-            <a:ext cx="5650992" cy="384048"/>
+            <a:ext cx="5650992" cy="512064"/>
           </a:xfrm>
           <a:prstGeom prst="rect">
             <a:avLst/>
@@ -25116,7 +25116,7 @@
                 <a:ea typeface="Arial" pitchFamily="34" charset="-122"/>
                 <a:cs typeface="Arial" pitchFamily="34" charset="-120"/>
               </a:rPr>
-              <a:t>Basis: 2.5 first reports a day per handler, the same before and after, that's inbound volume, not a capacity cap. What changes is the time each takes: 100 minutes a day, then 48. Confirmed by GGW (8 Sep 2026).</a:t>
+              <a:t>Basis: 2.5 first reports a day per handler (50 ÷ 20, both confirmed by GGW), the same before and after, that's inbound volume, not a capacity cap. At 40 min each, that's 100 minutes of an 8-hour shift today (~21%), 48 after (~10%). The rest of the day is the rest of the job: claims already open, not new intake.</a:t>
             </a:r>
             <a:endParaRPr lang="en-US" sz="860" dirty="0"/>
           </a:p>

</xml_diff>

<commit_message>
Retitle slide 1 around capacity, not the 52-minute figure
Title is now "Redesigning intake roughly doubles a claim handler's daily
capacity" (40 -> 19 min/claim, same 20 handlers, same shift). Subtitle
states the mechanism and the one caveat this number needs: it's a
capacity ceiling, not confirmed extra demand, matching how slide 8's
basis line already frames the same figure.

52 minutes is no longer in the title or subtitle, it stays visible in
the KPI row below, so the fully-sourced, no-caveat-needed number isn't
lost, it's just not fighting the headline for attention.

Co-Authored-By: Claude Sonnet 5 <noreply@anthropic.com>
Claude-Session: https://claude.ai/code/session_013ahPfefW92ASgTXBvzAPvh
</commit_message>
<xml_diff>
--- a/case-study/deck/GGW_FNOL_Redesign.pptx
+++ b/case-study/deck/GGW_FNOL_Redesign.pptx
@@ -1877,7 +1877,7 @@
                 <a:ea typeface="Cambria" pitchFamily="34" charset="-122"/>
                 <a:cs typeface="Cambria" pitchFamily="34" charset="-120"/>
               </a:rPr>
-              <a:t>Redesigning intake gives each claim handler back 52 minutes a day</a:t>
+              <a:t>Redesigning intake roughly doubles a claim handler's daily capacity</a:t>
             </a:r>
             <a:endParaRPr lang="en-US" sz="1900" dirty="0"/>
           </a:p>
@@ -1916,7 +1916,7 @@
                 <a:ea typeface="Arial" pitchFamily="34" charset="-122"/>
                 <a:cs typeface="Arial" pitchFamily="34" charset="-120"/>
               </a:rPr>
-              <a:t>17.5 hours a day across the 20 of them, or 2.8 full-time people. Most of it goes to the ~65% of claims that close at intake with no permanent injury.</a:t>
+              <a:t>Each claim drops from 40 to 19 minutes. Same 20 handlers, same shift: that's a capacity ceiling, not confirmed extra demand.</a:t>
             </a:r>
             <a:endParaRPr lang="en-US" sz="1050" dirty="0"/>
           </a:p>

</xml_diff>

<commit_message>
Compress slide 8's capacity basis line to two sentences
"At 40 minutes a claim, an 8-hour shift holds capacity for 12; at 19,
roughly 25. A ceiling, not the 52 minutes freed above. Confirmed by
GGW (8 Sep 2026)." Same figures, no rationale dropped, just stated
plainly instead of explained.

Co-Authored-By: Claude Sonnet 5 <noreply@anthropic.com>
Claude-Session: https://claude.ai/code/session_013ahPfefW92ASgTXBvzAPvh
</commit_message>
<xml_diff>
--- a/case-study/deck/GGW_FNOL_Redesign.pptx
+++ b/case-study/deck/GGW_FNOL_Redesign.pptx
@@ -26830,7 +26830,7 @@
         <p:spPr>
           <a:xfrm>
             <a:off x="365760" y="4224528"/>
-            <a:ext cx="5650992" cy="512064"/>
+            <a:ext cx="5650992" cy="384048"/>
           </a:xfrm>
           <a:prstGeom prst="rect">
             <a:avLst/>
@@ -26857,7 +26857,7 @@
                 <a:ea typeface="Arial" pitchFamily="34" charset="-122"/>
                 <a:cs typeface="Arial" pitchFamily="34" charset="-120"/>
               </a:rPr>
-              <a:t>Basis: at 40 minutes a claim, today's standard time, an 8-hour shift holds capacity for 12 claims; at 19 (the banked, most-likely estimate), capacity is ~25, roughly double. That's a ceiling, not the 52 minutes freed above, which is actual time freed on today's claim volume. Confirmed by GGW (8 Sep 2026).</a:t>
+              <a:t>Basis: at 40 minutes a claim, an 8-hour shift holds capacity for 12; at 19, roughly 25. A ceiling, not the 52 minutes freed above. Confirmed by GGW (8 Sep 2026).</a:t>
             </a:r>
             <a:endParaRPr lang="en-US" sz="860" dirty="0"/>
           </a:p>

</xml_diff>

<commit_message>
Replace slide 1's "52 min freed" KPI with a claims/day capacity tile
Adds a capacity-ceiling computation (productive hours / standard time
per claim) to economics.py and swaps the first exec-summary KPI tile
from minutes-freed to a 9 -> 19 claims/day capacity figure, which reads
less like a mundane time-saving and more like the doubled-capacity
story the rest of the deck makes. Slide 8's basis line is reworded to
match and no longer references the retired minutes-freed tile.

Co-Authored-By: Claude Sonnet 5 <noreply@anthropic.com>
Claude-Session: https://claude.ai/code/session_013ahPfefW92ASgTXBvzAPvh
</commit_message>
<xml_diff>
--- a/case-study/deck/GGW_FNOL_Redesign.pptx
+++ b/case-study/deck/GGW_FNOL_Redesign.pptx
@@ -3390,7 +3390,7 @@
                 <a:ea typeface="Cambria" pitchFamily="34" charset="-122"/>
                 <a:cs typeface="Cambria" pitchFamily="34" charset="-120"/>
               </a:rPr>
-              <a:t>52 min</a:t>
+              <a:t>9 → 19</a:t>
             </a:r>
             <a:endParaRPr lang="en-US" sz="2000" dirty="0"/>
           </a:p>
@@ -3432,7 +3432,7 @@
                 <a:ea typeface="Arial" pitchFamily="34" charset="-122"/>
                 <a:cs typeface="Arial" pitchFamily="34" charset="-120"/>
               </a:rPr>
-              <a:t>freed per claim handler per day, out of 6.0 productive hours</a:t>
+              <a:t>claims/day capacity per handler, a 6-hour day (ceiling, not added demand)</a:t>
             </a:r>
             <a:endParaRPr lang="en-US" sz="840" dirty="0"/>
           </a:p>
@@ -26857,7 +26857,7 @@
                 <a:ea typeface="Arial" pitchFamily="34" charset="-122"/>
                 <a:cs typeface="Arial" pitchFamily="34" charset="-120"/>
               </a:rPr>
-              <a:t>Basis: a 6-hour day holds capacity for 9 claims at 40 min each, ~19 claims at 19 min each. A ceiling, not the 52 minutes freed above. Confirmed by GGW (8 Sep 2026).</a:t>
+              <a:t>Basis: a 6-hour day holds capacity for 9 claims at 40 min each, ~19 at 19 min each. A ceiling: 50 claims/day actually arrive, not 180. Confirmed by GGW (8 Sep 2026).</a:t>
             </a:r>
             <a:endParaRPr lang="en-US" sz="860" dirty="0"/>
           </a:p>

</xml_diff>